<commit_message>
Fix Plarail electric image deck and QA metadata
</commit_message>
<xml_diff>
--- a/denken-shinkansen/01_shinkansen_vehicle_3/topics/01_plarail_electric/01_plarail_electric_images.pptx
+++ b/denken-shinkansen/01_shinkansen_vehicle_3/topics/01_plarail_electric/01_plarail_electric_images.pptx
@@ -721,41 +721,8 @@
         </p:nvSpPr>
         <p:spPr>
           <a:xfrm>
-            <a:off x="457200" y="320040"/>
-            <a:ext cx="11247120" cy="640080"/>
-          </a:xfrm>
-          <a:prstGeom prst="rect">
-            <a:avLst/>
-          </a:prstGeom>
-          <a:noFill/>
-        </p:spPr>
-        <p:txBody>
-          <a:bodyPr wrap="none">
-            <a:spAutoFit/>
-          </a:bodyPr>
-          <a:lstStyle/>
-          <a:p>
-            <a:r>
-              <a:rPr sz="2600" b="1">
-                <a:solidFill>
-                  <a:srgbClr val="000000"/>
-                </a:solidFill>
-              </a:rPr>
-              <a:t>01 プラレール① 電気編 — 電験三種・直流回路</a:t>
-            </a:r>
-          </a:p>
-        </p:txBody>
-      </p:sp>
-      <p:sp>
-        <p:nvSpPr>
-          <p:cNvPr id="3" name="TextBox 2"/>
-          <p:cNvSpPr txBox="1"/>
-          <p:nvPr/>
-        </p:nvSpPr>
-        <p:spPr>
-          <a:xfrm>
-            <a:off x="640080" y="1234440"/>
-            <a:ext cx="10881360" cy="4754880"/>
+            <a:off x="457200" y="228600"/>
+            <a:ext cx="11155680" cy="640080"/>
           </a:xfrm>
           <a:prstGeom prst="rect">
             <a:avLst/>
@@ -769,99 +736,365 @@
           <a:lstStyle/>
           <a:p>
             <a:r>
+              <a:rPr sz="2600" b="1">
+                <a:solidFill>
+                  <a:srgbClr val="000000"/>
+                </a:solidFill>
+              </a:rPr>
+              <a:t>01 プラレール① 電気編 — 電験三種・直流回路</a:t>
+            </a:r>
+          </a:p>
+        </p:txBody>
+      </p:sp>
+      <p:sp>
+        <p:nvSpPr>
+          <p:cNvPr id="3" name="Rounded Rectangle 2"/>
+          <p:cNvSpPr/>
+          <p:nvPr/>
+        </p:nvSpPr>
+        <p:spPr>
+          <a:xfrm>
+            <a:off x="640080" y="1188720"/>
+            <a:ext cx="1828800" cy="914400"/>
+          </a:xfrm>
+          <a:prstGeom prst="roundRect">
+            <a:avLst/>
+          </a:prstGeom>
+          <a:solidFill>
+            <a:srgbClr val="EBEBEB"/>
+          </a:solidFill>
+          <a:ln>
+            <a:solidFill>
+              <a:srgbClr val="000000"/>
+            </a:solidFill>
+          </a:ln>
+        </p:spPr>
+        <p:style>
+          <a:lnRef idx="1">
+            <a:schemeClr val="accent1"/>
+          </a:lnRef>
+          <a:fillRef idx="3">
+            <a:schemeClr val="accent1"/>
+          </a:fillRef>
+          <a:effectRef idx="2">
+            <a:schemeClr val="accent1"/>
+          </a:effectRef>
+          <a:fontRef idx="minor">
+            <a:schemeClr val="lt1"/>
+          </a:fontRef>
+        </p:style>
+        <p:txBody>
+          <a:bodyPr rtlCol="0"/>
+          <a:lstStyle/>
+          <a:p>
+            <a:pPr algn="ctr"/>
+            <a:r>
               <a:rPr sz="1800">
                 <a:solidFill>
                   <a:srgbClr val="000000"/>
                 </a:solidFill>
               </a:rPr>
-              <a:t>乾電池 1.5 V → スイッチ → 直流モーター</a:t>
-            </a:r>
-          </a:p>
-          <a:p/>
-          <a:p>
+              <a:t>乾電池</a:t>
+            </a:r>
+          </a:p>
+          <a:p>
+            <a:pPr algn="ctr"/>
             <a:r>
               <a:rPr sz="1800">
                 <a:solidFill>
                   <a:srgbClr val="000000"/>
                 </a:solidFill>
               </a:rPr>
-              <a:t>本試験で使う核</a:t>
-            </a:r>
-          </a:p>
-          <a:p>
+              <a:t>1.5 V</a:t>
+            </a:r>
+          </a:p>
+        </p:txBody>
+      </p:sp>
+      <p:sp>
+        <p:nvSpPr>
+          <p:cNvPr id="4" name="Rounded Rectangle 3"/>
+          <p:cNvSpPr/>
+          <p:nvPr/>
+        </p:nvSpPr>
+        <p:spPr>
+          <a:xfrm>
+            <a:off x="2971800" y="1188720"/>
+            <a:ext cx="1828800" cy="914400"/>
+          </a:xfrm>
+          <a:prstGeom prst="roundRect">
+            <a:avLst/>
+          </a:prstGeom>
+          <a:solidFill>
+            <a:srgbClr val="EBEBEB"/>
+          </a:solidFill>
+          <a:ln>
+            <a:solidFill>
+              <a:srgbClr val="000000"/>
+            </a:solidFill>
+          </a:ln>
+        </p:spPr>
+        <p:style>
+          <a:lnRef idx="1">
+            <a:schemeClr val="accent1"/>
+          </a:lnRef>
+          <a:fillRef idx="3">
+            <a:schemeClr val="accent1"/>
+          </a:fillRef>
+          <a:effectRef idx="2">
+            <a:schemeClr val="accent1"/>
+          </a:effectRef>
+          <a:fontRef idx="minor">
+            <a:schemeClr val="lt1"/>
+          </a:fontRef>
+        </p:style>
+        <p:txBody>
+          <a:bodyPr rtlCol="0"/>
+          <a:lstStyle/>
+          <a:p>
+            <a:pPr algn="ctr"/>
             <a:r>
               <a:rPr sz="1800">
                 <a:solidFill>
                   <a:srgbClr val="000000"/>
                 </a:solidFill>
               </a:rPr>
-              <a:t>V = RI　　KCL: ΣI=0　　KVL: ΣV=0</a:t>
-            </a:r>
-          </a:p>
-          <a:p>
+              <a:t>スイッチ</a:t>
+            </a:r>
+          </a:p>
+        </p:txBody>
+      </p:sp>
+      <p:sp>
+        <p:nvSpPr>
+          <p:cNvPr id="5" name="Rounded Rectangle 4"/>
+          <p:cNvSpPr/>
+          <p:nvPr/>
+        </p:nvSpPr>
+        <p:spPr>
+          <a:xfrm>
+            <a:off x="5303520" y="1188720"/>
+            <a:ext cx="1828800" cy="914400"/>
+          </a:xfrm>
+          <a:prstGeom prst="roundRect">
+            <a:avLst/>
+          </a:prstGeom>
+          <a:solidFill>
+            <a:srgbClr val="EBEBEB"/>
+          </a:solidFill>
+          <a:ln>
+            <a:solidFill>
+              <a:srgbClr val="000000"/>
+            </a:solidFill>
+          </a:ln>
+        </p:spPr>
+        <p:style>
+          <a:lnRef idx="1">
+            <a:schemeClr val="accent1"/>
+          </a:lnRef>
+          <a:fillRef idx="3">
+            <a:schemeClr val="accent1"/>
+          </a:fillRef>
+          <a:effectRef idx="2">
+            <a:schemeClr val="accent1"/>
+          </a:effectRef>
+          <a:fontRef idx="minor">
+            <a:schemeClr val="lt1"/>
+          </a:fontRef>
+        </p:style>
+        <p:txBody>
+          <a:bodyPr rtlCol="0"/>
+          <a:lstStyle/>
+          <a:p>
+            <a:pPr algn="ctr"/>
             <a:r>
               <a:rPr sz="1800">
                 <a:solidFill>
                   <a:srgbClr val="000000"/>
                 </a:solidFill>
               </a:rPr>
-              <a:t>P = VI = I²R = V²/R</a:t>
-            </a:r>
-          </a:p>
-          <a:p>
+              <a:t>直流モーター</a:t>
+            </a:r>
+          </a:p>
+          <a:p>
+            <a:pPr algn="ctr"/>
             <a:r>
               <a:rPr sz="1800">
                 <a:solidFill>
                   <a:srgbClr val="000000"/>
                 </a:solidFill>
               </a:rPr>
-              <a:t>直列: R=R1+R2　　並列: 1/R=1/R1+1/R2</a:t>
-            </a:r>
-          </a:p>
-          <a:p/>
-          <a:p>
+              <a:t>V = E + IaRa</a:t>
+            </a:r>
+          </a:p>
+        </p:txBody>
+      </p:sp>
+      <p:sp>
+        <p:nvSpPr>
+          <p:cNvPr id="6" name="Rounded Rectangle 5"/>
+          <p:cNvSpPr/>
+          <p:nvPr/>
+        </p:nvSpPr>
+        <p:spPr>
+          <a:xfrm>
+            <a:off x="7635240" y="1188720"/>
+            <a:ext cx="1828800" cy="914400"/>
+          </a:xfrm>
+          <a:prstGeom prst="roundRect">
+            <a:avLst/>
+          </a:prstGeom>
+          <a:solidFill>
+            <a:srgbClr val="EBEBEB"/>
+          </a:solidFill>
+          <a:ln>
+            <a:solidFill>
+              <a:srgbClr val="000000"/>
+            </a:solidFill>
+          </a:ln>
+        </p:spPr>
+        <p:style>
+          <a:lnRef idx="1">
+            <a:schemeClr val="accent1"/>
+          </a:lnRef>
+          <a:fillRef idx="3">
+            <a:schemeClr val="accent1"/>
+          </a:fillRef>
+          <a:effectRef idx="2">
+            <a:schemeClr val="accent1"/>
+          </a:effectRef>
+          <a:fontRef idx="minor">
+            <a:schemeClr val="lt1"/>
+          </a:fontRef>
+        </p:style>
+        <p:txBody>
+          <a:bodyPr rtlCol="0"/>
+          <a:lstStyle/>
+          <a:p>
+            <a:pPr algn="ctr"/>
             <a:r>
               <a:rPr sz="1800">
                 <a:solidFill>
                   <a:srgbClr val="000000"/>
                 </a:solidFill>
               </a:rPr>
-              <a:t>許容電力: Imax=√(Pmax/R), Vmax=√(Pmax R)</a:t>
-            </a:r>
-          </a:p>
-          <a:p>
-            <a:r>
-              <a:rPr sz="1800">
-                <a:solidFill>
-                  <a:srgbClr val="000000"/>
-                </a:solidFill>
-              </a:rPr>
-              <a:t>直流電動機: V = E + IaRa（回転中は逆起電力 E を考える）</a:t>
-            </a:r>
-          </a:p>
-          <a:p/>
-          <a:p>
-            <a:r>
-              <a:rPr sz="1800">
-                <a:solidFill>
-                  <a:srgbClr val="000000"/>
-                </a:solidFill>
-              </a:rPr>
-              <a:t>解法: 回路を直列/並列に分解 → 単位統一 → 合成抵抗 → 電流/電圧 → 電力 → 選択肢照合</a:t>
-            </a:r>
-          </a:p>
-        </p:txBody>
-      </p:sp>
-      <p:sp>
-        <p:nvSpPr>
-          <p:cNvPr id="4" name="TextBox 3"/>
+              <a:t>車輪</a:t>
+            </a:r>
+          </a:p>
+        </p:txBody>
+      </p:sp>
+      <p:cxnSp>
+        <p:nvCxnSpPr>
+          <p:cNvPr id="7" name="Connector 6"/>
+          <p:cNvCxnSpPr/>
+          <p:nvPr/>
+        </p:nvCxnSpPr>
+        <p:spPr>
+          <a:xfrm>
+            <a:off x="2468880" y="1645920"/>
+            <a:ext cx="502920" cy="0"/>
+          </a:xfrm>
+          <a:prstGeom prst="line">
+            <a:avLst/>
+          </a:prstGeom>
+          <a:ln w="25400">
+            <a:solidFill>
+              <a:srgbClr val="000000"/>
+            </a:solidFill>
+          </a:ln>
+        </p:spPr>
+        <p:style>
+          <a:lnRef idx="2">
+            <a:schemeClr val="accent1"/>
+          </a:lnRef>
+          <a:fillRef idx="0">
+            <a:schemeClr val="accent1"/>
+          </a:fillRef>
+          <a:effectRef idx="1">
+            <a:schemeClr val="accent1"/>
+          </a:effectRef>
+          <a:fontRef idx="minor">
+            <a:schemeClr val="tx1"/>
+          </a:fontRef>
+        </p:style>
+      </p:cxnSp>
+      <p:cxnSp>
+        <p:nvCxnSpPr>
+          <p:cNvPr id="8" name="Connector 7"/>
+          <p:cNvCxnSpPr/>
+          <p:nvPr/>
+        </p:nvCxnSpPr>
+        <p:spPr>
+          <a:xfrm>
+            <a:off x="4800600" y="1645920"/>
+            <a:ext cx="502920" cy="0"/>
+          </a:xfrm>
+          <a:prstGeom prst="line">
+            <a:avLst/>
+          </a:prstGeom>
+          <a:ln w="25400">
+            <a:solidFill>
+              <a:srgbClr val="000000"/>
+            </a:solidFill>
+          </a:ln>
+        </p:spPr>
+        <p:style>
+          <a:lnRef idx="2">
+            <a:schemeClr val="accent1"/>
+          </a:lnRef>
+          <a:fillRef idx="0">
+            <a:schemeClr val="accent1"/>
+          </a:fillRef>
+          <a:effectRef idx="1">
+            <a:schemeClr val="accent1"/>
+          </a:effectRef>
+          <a:fontRef idx="minor">
+            <a:schemeClr val="tx1"/>
+          </a:fontRef>
+        </p:style>
+      </p:cxnSp>
+      <p:cxnSp>
+        <p:nvCxnSpPr>
+          <p:cNvPr id="9" name="Connector 8"/>
+          <p:cNvCxnSpPr/>
+          <p:nvPr/>
+        </p:nvCxnSpPr>
+        <p:spPr>
+          <a:xfrm>
+            <a:off x="7132320" y="1645920"/>
+            <a:ext cx="502920" cy="0"/>
+          </a:xfrm>
+          <a:prstGeom prst="line">
+            <a:avLst/>
+          </a:prstGeom>
+          <a:ln w="25400">
+            <a:solidFill>
+              <a:srgbClr val="000000"/>
+            </a:solidFill>
+          </a:ln>
+        </p:spPr>
+        <p:style>
+          <a:lnRef idx="2">
+            <a:schemeClr val="accent1"/>
+          </a:lnRef>
+          <a:fillRef idx="0">
+            <a:schemeClr val="accent1"/>
+          </a:fillRef>
+          <a:effectRef idx="1">
+            <a:schemeClr val="accent1"/>
+          </a:effectRef>
+          <a:fontRef idx="minor">
+            <a:schemeClr val="tx1"/>
+          </a:fontRef>
+        </p:style>
+      </p:cxnSp>
+      <p:sp>
+        <p:nvSpPr>
+          <p:cNvPr id="10" name="TextBox 9"/>
           <p:cNvSpPr txBox="1"/>
           <p:nvPr/>
         </p:nvSpPr>
         <p:spPr>
           <a:xfrm>
-            <a:off x="457200" y="6400800"/>
-            <a:ext cx="11247120" cy="274320"/>
+            <a:off x="640080" y="2377440"/>
+            <a:ext cx="5303520" cy="411480"/>
           </a:xfrm>
           <a:prstGeom prst="rect">
             <a:avLst/>
@@ -869,18 +1102,360 @@
           <a:noFill/>
         </p:spPr>
         <p:txBody>
-          <a:bodyPr wrap="none">
+          <a:bodyPr wrap="square">
             <a:spAutoFit/>
           </a:bodyPr>
           <a:lstStyle/>
           <a:p>
             <a:r>
-              <a:rPr sz="800">
-                <a:solidFill>
-                  <a:srgbClr val="000000"/>
-                </a:solidFill>
-              </a:rPr>
-              <a:t>出典: 電気技術者試験センター第三種過去問題; e-sysnet 直流回路/消費電力; タカラトミー; Panasonic（参照日 2026-08-29）</a:t>
+              <a:rPr sz="2000" b="1">
+                <a:solidFill>
+                  <a:srgbClr val="000000"/>
+                </a:solidFill>
+              </a:rPr>
+              <a:t>本試験で使う回路の読み方</a:t>
+            </a:r>
+          </a:p>
+        </p:txBody>
+      </p:sp>
+      <p:sp>
+        <p:nvSpPr>
+          <p:cNvPr id="11" name="Rounded Rectangle 10"/>
+          <p:cNvSpPr/>
+          <p:nvPr/>
+        </p:nvSpPr>
+        <p:spPr>
+          <a:xfrm>
+            <a:off x="731520" y="2971800"/>
+            <a:ext cx="1371600" cy="685800"/>
+          </a:xfrm>
+          <a:prstGeom prst="roundRect">
+            <a:avLst/>
+          </a:prstGeom>
+          <a:solidFill>
+            <a:srgbClr val="EBEBEB"/>
+          </a:solidFill>
+          <a:ln>
+            <a:solidFill>
+              <a:srgbClr val="000000"/>
+            </a:solidFill>
+          </a:ln>
+        </p:spPr>
+        <p:style>
+          <a:lnRef idx="1">
+            <a:schemeClr val="accent1"/>
+          </a:lnRef>
+          <a:fillRef idx="3">
+            <a:schemeClr val="accent1"/>
+          </a:fillRef>
+          <a:effectRef idx="2">
+            <a:schemeClr val="accent1"/>
+          </a:effectRef>
+          <a:fontRef idx="minor">
+            <a:schemeClr val="lt1"/>
+          </a:fontRef>
+        </p:style>
+        <p:txBody>
+          <a:bodyPr rtlCol="0"/>
+          <a:lstStyle/>
+          <a:p>
+            <a:pPr algn="ctr"/>
+            <a:r>
+              <a:rPr sz="1800">
+                <a:solidFill>
+                  <a:srgbClr val="000000"/>
+                </a:solidFill>
+              </a:rPr>
+              <a:t>電源 V</a:t>
+            </a:r>
+          </a:p>
+        </p:txBody>
+      </p:sp>
+      <p:sp>
+        <p:nvSpPr>
+          <p:cNvPr id="12" name="Rounded Rectangle 11"/>
+          <p:cNvSpPr/>
+          <p:nvPr/>
+        </p:nvSpPr>
+        <p:spPr>
+          <a:xfrm>
+            <a:off x="2926080" y="2971800"/>
+            <a:ext cx="1371600" cy="685800"/>
+          </a:xfrm>
+          <a:prstGeom prst="roundRect">
+            <a:avLst/>
+          </a:prstGeom>
+          <a:solidFill>
+            <a:srgbClr val="EBEBEB"/>
+          </a:solidFill>
+          <a:ln>
+            <a:solidFill>
+              <a:srgbClr val="000000"/>
+            </a:solidFill>
+          </a:ln>
+        </p:spPr>
+        <p:style>
+          <a:lnRef idx="1">
+            <a:schemeClr val="accent1"/>
+          </a:lnRef>
+          <a:fillRef idx="3">
+            <a:schemeClr val="accent1"/>
+          </a:fillRef>
+          <a:effectRef idx="2">
+            <a:schemeClr val="accent1"/>
+          </a:effectRef>
+          <a:fontRef idx="minor">
+            <a:schemeClr val="lt1"/>
+          </a:fontRef>
+        </p:style>
+        <p:txBody>
+          <a:bodyPr rtlCol="0"/>
+          <a:lstStyle/>
+          <a:p>
+            <a:pPr algn="ctr"/>
+            <a:r>
+              <a:rPr sz="1800">
+                <a:solidFill>
+                  <a:srgbClr val="000000"/>
+                </a:solidFill>
+              </a:rPr>
+              <a:t>R1</a:t>
+            </a:r>
+          </a:p>
+        </p:txBody>
+      </p:sp>
+      <p:sp>
+        <p:nvSpPr>
+          <p:cNvPr id="13" name="Rounded Rectangle 12"/>
+          <p:cNvSpPr/>
+          <p:nvPr/>
+        </p:nvSpPr>
+        <p:spPr>
+          <a:xfrm>
+            <a:off x="5120640" y="2971800"/>
+            <a:ext cx="1371600" cy="685800"/>
+          </a:xfrm>
+          <a:prstGeom prst="roundRect">
+            <a:avLst/>
+          </a:prstGeom>
+          <a:solidFill>
+            <a:srgbClr val="EBEBEB"/>
+          </a:solidFill>
+          <a:ln>
+            <a:solidFill>
+              <a:srgbClr val="000000"/>
+            </a:solidFill>
+          </a:ln>
+        </p:spPr>
+        <p:style>
+          <a:lnRef idx="1">
+            <a:schemeClr val="accent1"/>
+          </a:lnRef>
+          <a:fillRef idx="3">
+            <a:schemeClr val="accent1"/>
+          </a:fillRef>
+          <a:effectRef idx="2">
+            <a:schemeClr val="accent1"/>
+          </a:effectRef>
+          <a:fontRef idx="minor">
+            <a:schemeClr val="lt1"/>
+          </a:fontRef>
+        </p:style>
+        <p:txBody>
+          <a:bodyPr rtlCol="0"/>
+          <a:lstStyle/>
+          <a:p>
+            <a:pPr algn="ctr"/>
+            <a:r>
+              <a:rPr sz="1800">
+                <a:solidFill>
+                  <a:srgbClr val="000000"/>
+                </a:solidFill>
+              </a:rPr>
+              <a:t>R2</a:t>
+            </a:r>
+          </a:p>
+        </p:txBody>
+      </p:sp>
+      <p:sp>
+        <p:nvSpPr>
+          <p:cNvPr id="14" name="TextBox 13"/>
+          <p:cNvSpPr txBox="1"/>
+          <p:nvPr/>
+        </p:nvSpPr>
+        <p:spPr>
+          <a:xfrm>
+            <a:off x="822960" y="3886200"/>
+            <a:ext cx="5852160" cy="1188720"/>
+          </a:xfrm>
+          <a:prstGeom prst="rect">
+            <a:avLst/>
+          </a:prstGeom>
+          <a:noFill/>
+        </p:spPr>
+        <p:txBody>
+          <a:bodyPr wrap="square">
+            <a:spAutoFit/>
+          </a:bodyPr>
+          <a:lstStyle/>
+          <a:p>
+            <a:r>
+              <a:rPr sz="1800" b="0">
+                <a:solidFill>
+                  <a:srgbClr val="000000"/>
+                </a:solidFill>
+              </a:rPr>
+              <a:t>直列: R = R1 + R2</a:t>
+            </a:r>
+          </a:p>
+          <a:p>
+            <a:r>
+              <a:rPr sz="1800" b="0">
+                <a:solidFill>
+                  <a:srgbClr val="000000"/>
+                </a:solidFill>
+              </a:rPr>
+              <a:t>並列: 1/R = 1/R1 + 1/R2</a:t>
+            </a:r>
+          </a:p>
+          <a:p>
+            <a:r>
+              <a:rPr sz="1800" b="0">
+                <a:solidFill>
+                  <a:srgbClr val="000000"/>
+                </a:solidFill>
+              </a:rPr>
+              <a:t>KCL: ΣI = 0　　KVL: ΣV = 0</a:t>
+            </a:r>
+          </a:p>
+        </p:txBody>
+      </p:sp>
+      <p:sp>
+        <p:nvSpPr>
+          <p:cNvPr id="15" name="TextBox 14"/>
+          <p:cNvSpPr txBox="1"/>
+          <p:nvPr/>
+        </p:nvSpPr>
+        <p:spPr>
+          <a:xfrm>
+            <a:off x="6766560" y="2423160"/>
+            <a:ext cx="4663440" cy="411480"/>
+          </a:xfrm>
+          <a:prstGeom prst="rect">
+            <a:avLst/>
+          </a:prstGeom>
+          <a:noFill/>
+        </p:spPr>
+        <p:txBody>
+          <a:bodyPr wrap="square">
+            <a:spAutoFit/>
+          </a:bodyPr>
+          <a:lstStyle/>
+          <a:p>
+            <a:r>
+              <a:rPr sz="2000" b="1">
+                <a:solidFill>
+                  <a:srgbClr val="000000"/>
+                </a:solidFill>
+              </a:rPr>
+              <a:t>電力・許容電力</a:t>
+            </a:r>
+          </a:p>
+        </p:txBody>
+      </p:sp>
+      <p:sp>
+        <p:nvSpPr>
+          <p:cNvPr id="16" name="TextBox 15"/>
+          <p:cNvSpPr txBox="1"/>
+          <p:nvPr/>
+        </p:nvSpPr>
+        <p:spPr>
+          <a:xfrm>
+            <a:off x="6766560" y="2971800"/>
+            <a:ext cx="4663440" cy="1645920"/>
+          </a:xfrm>
+          <a:prstGeom prst="rect">
+            <a:avLst/>
+          </a:prstGeom>
+          <a:noFill/>
+        </p:spPr>
+        <p:txBody>
+          <a:bodyPr wrap="square">
+            <a:spAutoFit/>
+          </a:bodyPr>
+          <a:lstStyle/>
+          <a:p>
+            <a:r>
+              <a:rPr sz="1800" b="0">
+                <a:solidFill>
+                  <a:srgbClr val="000000"/>
+                </a:solidFill>
+              </a:rPr>
+              <a:t>P = VI = I²R = V²/R</a:t>
+            </a:r>
+          </a:p>
+          <a:p>
+            <a:r>
+              <a:rPr sz="1800" b="0">
+                <a:solidFill>
+                  <a:srgbClr val="000000"/>
+                </a:solidFill>
+              </a:rPr>
+              <a:t>Imax = √(Pmax/R)</a:t>
+            </a:r>
+          </a:p>
+          <a:p>
+            <a:r>
+              <a:rPr sz="1800" b="0">
+                <a:solidFill>
+                  <a:srgbClr val="000000"/>
+                </a:solidFill>
+              </a:rPr>
+              <a:t>Vmax = √(Pmax R)</a:t>
+            </a:r>
+          </a:p>
+          <a:p/>
+          <a:p>
+            <a:r>
+              <a:rPr sz="1800" b="0">
+                <a:solidFill>
+                  <a:srgbClr val="000000"/>
+                </a:solidFill>
+              </a:rPr>
+              <a:t>解法: 単位統一 → 合成抵抗 → 電流/電圧 → 電力 → 選択肢照合</a:t>
+            </a:r>
+          </a:p>
+        </p:txBody>
+      </p:sp>
+      <p:sp>
+        <p:nvSpPr>
+          <p:cNvPr id="17" name="TextBox 16"/>
+          <p:cNvSpPr txBox="1"/>
+          <p:nvPr/>
+        </p:nvSpPr>
+        <p:spPr>
+          <a:xfrm>
+            <a:off x="457200" y="6400800"/>
+            <a:ext cx="11247120" cy="256032"/>
+          </a:xfrm>
+          <a:prstGeom prst="rect">
+            <a:avLst/>
+          </a:prstGeom>
+          <a:noFill/>
+        </p:spPr>
+        <p:txBody>
+          <a:bodyPr wrap="square">
+            <a:spAutoFit/>
+          </a:bodyPr>
+          <a:lstStyle/>
+          <a:p>
+            <a:r>
+              <a:rPr sz="800" b="0">
+                <a:solidFill>
+                  <a:srgbClr val="000000"/>
+                </a:solidFill>
+              </a:rPr>
+              <a:t>出典: 電気技術者試験センター第三種過去問題; e-sysnet 直流回路/消費電力; タカラトミー; Panasonic（参照日 2026-08-29）。図は自作模式図。</a:t>
             </a:r>
           </a:p>
         </p:txBody>
@@ -911,8 +1486,8 @@
         </p:nvSpPr>
         <p:spPr>
           <a:xfrm>
-            <a:off x="457200" y="320040"/>
-            <a:ext cx="11247120" cy="640080"/>
+            <a:off x="457200" y="274320"/>
+            <a:ext cx="11155680" cy="640080"/>
           </a:xfrm>
           <a:prstGeom prst="rect">
             <a:avLst/>
@@ -920,13 +1495,13 @@
           <a:noFill/>
         </p:spPr>
         <p:txBody>
-          <a:bodyPr wrap="none">
+          <a:bodyPr wrap="square">
             <a:spAutoFit/>
           </a:bodyPr>
           <a:lstStyle/>
           <a:p>
             <a:r>
-              <a:rPr sz="2600" b="1">
+              <a:rPr sz="2800" b="1">
                 <a:solidFill>
                   <a:srgbClr val="000000"/>
                 </a:solidFill>
@@ -944,8 +1519,8 @@
         </p:nvSpPr>
         <p:spPr>
           <a:xfrm>
-            <a:off x="640080" y="1234440"/>
-            <a:ext cx="10881360" cy="4754880"/>
+            <a:off x="640080" y="1143000"/>
+            <a:ext cx="10972800" cy="5029200"/>
           </a:xfrm>
           <a:prstGeom prst="rect">
             <a:avLst/>
@@ -959,7 +1534,7 @@
           <a:lstStyle/>
           <a:p>
             <a:r>
-              <a:rPr sz="1400">
+              <a:rPr sz="1500" b="0">
                 <a:solidFill>
                   <a:srgbClr val="000000"/>
                 </a:solidFill>
@@ -969,18 +1544,18 @@
           </a:p>
           <a:p>
             <a:r>
-              <a:rPr sz="1400">
-                <a:solidFill>
-                  <a:srgbClr val="000000"/>
-                </a:solidFill>
-              </a:rPr>
-              <a:t>   https://www.shiken.or.jp/chief/third/qa/ — H27理論Q4, H30理論Q5/Q6, R2理論Q6, R4上理論Q5（参照日 2026-08-29）</a:t>
+              <a:rPr sz="1500" b="0">
+                <a:solidFill>
+                  <a:srgbClr val="000000"/>
+                </a:solidFill>
+              </a:rPr>
+              <a:t>   https://www.shiken.or.jp/chief/third/qa/ — H27 理論Q4, H30 理論Q5/Q6, R2 理論Q6, R4上 理論Q5（参照日 2026-08-29）</a:t>
             </a:r>
           </a:p>
           <a:p/>
           <a:p>
             <a:r>
-              <a:rPr sz="1400">
+              <a:rPr sz="1500" b="0">
                 <a:solidFill>
                   <a:srgbClr val="000000"/>
                 </a:solidFill>
@@ -990,7 +1565,7 @@
           </a:p>
           <a:p>
             <a:r>
-              <a:rPr sz="1400">
+              <a:rPr sz="1500" b="0">
                 <a:solidFill>
                   <a:srgbClr val="000000"/>
                 </a:solidFill>
@@ -1001,7 +1576,7 @@
           <a:p/>
           <a:p>
             <a:r>
-              <a:rPr sz="1400">
+              <a:rPr sz="1500" b="0">
                 <a:solidFill>
                   <a:srgbClr val="000000"/>
                 </a:solidFill>
@@ -1011,7 +1586,7 @@
           </a:p>
           <a:p>
             <a:r>
-              <a:rPr sz="1400">
+              <a:rPr sz="1500" b="0">
                 <a:solidFill>
                   <a:srgbClr val="000000"/>
                 </a:solidFill>
@@ -1022,7 +1597,7 @@
           <a:p/>
           <a:p>
             <a:r>
-              <a:rPr sz="1400">
+              <a:rPr sz="1500" b="0">
                 <a:solidFill>
                   <a:srgbClr val="000000"/>
                 </a:solidFill>
@@ -1032,7 +1607,7 @@
           </a:p>
           <a:p>
             <a:r>
-              <a:rPr sz="1400">
+              <a:rPr sz="1500" b="0">
                 <a:solidFill>
                   <a:srgbClr val="000000"/>
                 </a:solidFill>
@@ -1051,7 +1626,7 @@
         <p:spPr>
           <a:xfrm>
             <a:off x="457200" y="6400800"/>
-            <a:ext cx="11247120" cy="274320"/>
+            <a:ext cx="11247120" cy="256032"/>
           </a:xfrm>
           <a:prstGeom prst="rect">
             <a:avLst/>
@@ -1059,18 +1634,18 @@
           <a:noFill/>
         </p:spPr>
         <p:txBody>
-          <a:bodyPr wrap="none">
+          <a:bodyPr wrap="square">
             <a:spAutoFit/>
           </a:bodyPr>
           <a:lstStyle/>
           <a:p>
             <a:r>
-              <a:rPr sz="800">
-                <a:solidFill>
-                  <a:srgbClr val="000000"/>
-                </a:solidFill>
-              </a:rPr>
-              <a:t>引用画像なし。図・回路表現は自作模式図。</a:t>
+              <a:rPr sz="800" b="0">
+                <a:solidFill>
+                  <a:srgbClr val="000000"/>
+                </a:solidFill>
+              </a:rPr>
+              <a:t>引用画像なし。車両・回路・エネルギーフローは自作模式図。</a:t>
             </a:r>
           </a:p>
         </p:txBody>

</xml_diff>